<commit_message>
wip: snapshot arbre BMAD mi-migration avant reinstall claude-code-only
Baseline reversible avant reinstallation BMAD (--tools claude-code) et
suppression de la copie Codex (.agents/skills). Capture l'etat non commite
de la montee de version BMAD (manifest lastUpdated 2026-07-16) pour isoler
le diff de la reinstall.

Co-Authored-By: Claude Opus 4.8 (1M context) <noreply@anthropic.com>
</commit_message>
<xml_diff>
--- a/comop-pptx-prototype/templates/comop-template.pptx
+++ b/comop-pptx-prototype/templates/comop-template.pptx
@@ -26408,42 +26408,6 @@
           </a:p>
         </p:txBody>
       </p:sp>
-      <p:pic>
-        <p:nvPicPr>
-          <p:cNvPr id="305" name="Google Shape;305;g3072d353d33_0_186"/>
-          <p:cNvPicPr preferRelativeResize="0"/>
-          <p:nvPr/>
-        </p:nvPicPr>
-        <p:blipFill>
-          <a:blip r:embed="rId3">
-            <a:alphaModFix/>
-          </a:blip>
-          <a:stretch>
-            <a:fillRect/>
-          </a:stretch>
-        </p:blipFill>
-        <p:spPr>
-          <a:xfrm>
-            <a:off x="7274250" y="1819800"/>
-            <a:ext cx="1788900" cy="1254885"/>
-          </a:xfrm>
-          <a:prstGeom prst="rect">
-            <a:avLst/>
-          </a:prstGeom>
-          <a:solidFill>
-            <a:srgbClr val="FFFFFF"/>
-          </a:solidFill>
-          <a:ln w="9525" cap="flat" cmpd="sng">
-            <a:solidFill>
-              <a:srgbClr val="0E2356"/>
-            </a:solidFill>
-            <a:prstDash val="solid"/>
-            <a:miter lim="8000"/>
-            <a:headEnd type="none" w="sm" len="sm"/>
-            <a:tailEnd type="none" w="sm" len="sm"/>
-          </a:ln>
-        </p:spPr>
-      </p:pic>
       <p:sp>
         <p:nvSpPr>
           <p:cNvPr id="306" name="Google Shape;306;g3072d353d33_0_186"/>
@@ -31631,34 +31595,6 @@
           </p:txBody>
         </p:sp>
       </p:grpSp>
-      <p:pic>
-        <p:nvPicPr>
-          <p:cNvPr id="371" name="Google Shape;371;g3072d353d33_0_212"/>
-          <p:cNvPicPr preferRelativeResize="0"/>
-          <p:nvPr/>
-        </p:nvPicPr>
-        <p:blipFill>
-          <a:blip r:embed="rId3">
-            <a:alphaModFix/>
-          </a:blip>
-          <a:stretch>
-            <a:fillRect/>
-          </a:stretch>
-        </p:blipFill>
-        <p:spPr>
-          <a:xfrm>
-            <a:off x="396400" y="1014450"/>
-            <a:ext cx="5570299" cy="2613793"/>
-          </a:xfrm>
-          <a:prstGeom prst="rect">
-            <a:avLst/>
-          </a:prstGeom>
-          <a:noFill/>
-          <a:ln>
-            <a:noFill/>
-          </a:ln>
-        </p:spPr>
-      </p:pic>
       <p:sp>
         <p:nvSpPr>
           <p:cNvPr id="372" name="Google Shape;372;g3072d353d33_0_212"/>
@@ -31945,654 +31881,6 @@
           </a:p>
         </p:txBody>
       </p:sp>
-      <p:graphicFrame>
-        <p:nvGraphicFramePr>
-          <p:cNvPr id="375" name="Google Shape;375;g3072d353d33_0_212"/>
-          <p:cNvGraphicFramePr/>
-          <p:nvPr/>
-        </p:nvGraphicFramePr>
-        <p:xfrm>
-          <a:off x="155327" y="3879095"/>
-          <a:ext cx="8901300" cy="775360"/>
-        </p:xfrm>
-        <a:graphic>
-          <a:graphicData uri="http://schemas.openxmlformats.org/drawingml/2006/table">
-            <a:tbl>
-              <a:tblPr>
-                <a:noFill/>
-                <a:tableStyleId>{0E937493-311C-4B09-AB42-98F83098D3E6}</a:tableStyleId>
-              </a:tblPr>
-              <a:tblGrid>
-                <a:gridCol w="580825">
-                  <a:extLst>
-                    <a:ext uri="{9D8B030D-6E8A-4147-A177-3AD203B41FA5}">
-                      <a16:colId xmlns:a16="http://schemas.microsoft.com/office/drawing/2014/main" val="20000"/>
-                    </a:ext>
-                  </a:extLst>
-                </a:gridCol>
-                <a:gridCol w="5230550">
-                  <a:extLst>
-                    <a:ext uri="{9D8B030D-6E8A-4147-A177-3AD203B41FA5}">
-                      <a16:colId xmlns:a16="http://schemas.microsoft.com/office/drawing/2014/main" val="20001"/>
-                    </a:ext>
-                  </a:extLst>
-                </a:gridCol>
-                <a:gridCol w="3089925">
-                  <a:extLst>
-                    <a:ext uri="{9D8B030D-6E8A-4147-A177-3AD203B41FA5}">
-                      <a16:colId xmlns:a16="http://schemas.microsoft.com/office/drawing/2014/main" val="20002"/>
-                    </a:ext>
-                  </a:extLst>
-                </a:gridCol>
-              </a:tblGrid>
-              <a:tr h="188125">
-                <a:tc>
-                  <a:txBody>
-                    <a:bodyPr/>
-                    <a:lstStyle/>
-                    <a:p>
-                      <a:pPr marL="0" marR="0" lvl="0" indent="0" algn="ctr" rtl="0">
-                        <a:lnSpc>
-                          <a:spcPct val="100000"/>
-                        </a:lnSpc>
-                        <a:spcBef>
-                          <a:spcPts val="0"/>
-                        </a:spcBef>
-                        <a:spcAft>
-                          <a:spcPts val="0"/>
-                        </a:spcAft>
-                        <a:buClr>
-                          <a:srgbClr val="FFFFFF"/>
-                        </a:buClr>
-                        <a:buSzPts val="1400"/>
-                        <a:buFont typeface="Outfit"/>
-                        <a:buNone/>
-                      </a:pPr>
-                      <a:r>
-                        <a:rPr lang="en-US" sz="1400" b="1" i="0" u="none" strike="noStrike" cap="none">
-                          <a:solidFill>
-                            <a:srgbClr val="FFFFFF"/>
-                          </a:solidFill>
-                          <a:latin typeface="Outfit"/>
-                          <a:ea typeface="Outfit"/>
-                          <a:cs typeface="Outfit"/>
-                          <a:sym typeface="Outfit"/>
-                        </a:rPr>
-                        <a:t>🕭</a:t>
-                      </a:r>
-                      <a:endParaRPr sz="2000" b="1" u="none" strike="noStrike" cap="none">
-                        <a:solidFill>
-                          <a:srgbClr val="FFFFFF"/>
-                        </a:solidFill>
-                        <a:latin typeface="Outfit"/>
-                        <a:ea typeface="Outfit"/>
-                        <a:cs typeface="Outfit"/>
-                        <a:sym typeface="Outfit"/>
-                      </a:endParaRPr>
-                    </a:p>
-                  </a:txBody>
-                  <a:tcPr marL="68575" marR="68575" marT="0" marB="0" anchor="ctr">
-                    <a:lnL w="12700" cap="flat" cmpd="sng">
-                      <a:solidFill>
-                        <a:srgbClr val="0E2356"/>
-                      </a:solidFill>
-                      <a:prstDash val="solid"/>
-                      <a:round/>
-                      <a:headEnd type="none" w="sm" len="sm"/>
-                      <a:tailEnd type="none" w="sm" len="sm"/>
-                    </a:lnL>
-                    <a:lnR w="12700" cap="flat" cmpd="sng">
-                      <a:solidFill>
-                        <a:srgbClr val="0E2356"/>
-                      </a:solidFill>
-                      <a:prstDash val="solid"/>
-                      <a:round/>
-                      <a:headEnd type="none" w="sm" len="sm"/>
-                      <a:tailEnd type="none" w="sm" len="sm"/>
-                    </a:lnR>
-                    <a:lnT w="12700" cap="flat" cmpd="sng">
-                      <a:solidFill>
-                        <a:srgbClr val="0E2356"/>
-                      </a:solidFill>
-                      <a:prstDash val="solid"/>
-                      <a:round/>
-                      <a:headEnd type="none" w="sm" len="sm"/>
-                      <a:tailEnd type="none" w="sm" len="sm"/>
-                    </a:lnT>
-                    <a:lnB w="12700" cap="flat" cmpd="sng">
-                      <a:solidFill>
-                        <a:srgbClr val="0E2356"/>
-                      </a:solidFill>
-                      <a:prstDash val="solid"/>
-                      <a:round/>
-                      <a:headEnd type="none" w="sm" len="sm"/>
-                      <a:tailEnd type="none" w="sm" len="sm"/>
-                    </a:lnB>
-                    <a:solidFill>
-                      <a:srgbClr val="C5D9E8"/>
-                    </a:solidFill>
-                  </a:tcPr>
-                </a:tc>
-                <a:tc>
-                  <a:txBody>
-                    <a:bodyPr/>
-                    <a:lstStyle/>
-                    <a:p>
-                      <a:pPr marL="0" marR="0" lvl="0" indent="0" algn="ctr" rtl="0">
-                        <a:lnSpc>
-                          <a:spcPct val="100000"/>
-                        </a:lnSpc>
-                        <a:spcBef>
-                          <a:spcPts val="0"/>
-                        </a:spcBef>
-                        <a:spcAft>
-                          <a:spcPts val="0"/>
-                        </a:spcAft>
-                        <a:buClr>
-                          <a:srgbClr val="0E2356"/>
-                        </a:buClr>
-                        <a:buSzPts val="700"/>
-                        <a:buFont typeface="Outfit"/>
-                        <a:buNone/>
-                      </a:pPr>
-                      <a:r>
-                        <a:rPr lang="en-US" sz="900" b="1" i="0" u="none" strike="noStrike" cap="none">
-                          <a:solidFill>
-                            <a:srgbClr val="0E2356"/>
-                          </a:solidFill>
-                          <a:latin typeface="Outfit"/>
-                          <a:ea typeface="Outfit"/>
-                          <a:cs typeface="Outfit"/>
-                          <a:sym typeface="Outfit"/>
-                        </a:rPr>
-                        <a:t>Sujets pour décision</a:t>
-                      </a:r>
-                      <a:r>
-                        <a:rPr lang="en-US" sz="900" b="1">
-                          <a:latin typeface="Outfit"/>
-                          <a:ea typeface="Outfit"/>
-                          <a:cs typeface="Outfit"/>
-                          <a:sym typeface="Outfit"/>
-                        </a:rPr>
-                        <a:t>(s)</a:t>
-                      </a:r>
-                      <a:endParaRPr sz="900" b="1" i="0" u="none" strike="noStrike" cap="none">
-                        <a:solidFill>
-                          <a:srgbClr val="0E2356"/>
-                        </a:solidFill>
-                        <a:latin typeface="Outfit"/>
-                        <a:ea typeface="Outfit"/>
-                        <a:cs typeface="Outfit"/>
-                        <a:sym typeface="Outfit"/>
-                      </a:endParaRPr>
-                    </a:p>
-                  </a:txBody>
-                  <a:tcPr marL="68575" marR="68575" marT="0" marB="0" anchor="ctr">
-                    <a:lnL w="12700" cap="flat" cmpd="sng">
-                      <a:solidFill>
-                        <a:srgbClr val="0E2356"/>
-                      </a:solidFill>
-                      <a:prstDash val="solid"/>
-                      <a:round/>
-                      <a:headEnd type="none" w="sm" len="sm"/>
-                      <a:tailEnd type="none" w="sm" len="sm"/>
-                    </a:lnL>
-                    <a:lnR w="12700" cap="flat" cmpd="sng">
-                      <a:solidFill>
-                        <a:srgbClr val="0E2356"/>
-                      </a:solidFill>
-                      <a:prstDash val="solid"/>
-                      <a:round/>
-                      <a:headEnd type="none" w="sm" len="sm"/>
-                      <a:tailEnd type="none" w="sm" len="sm"/>
-                    </a:lnR>
-                    <a:lnT w="12700" cap="flat" cmpd="sng">
-                      <a:solidFill>
-                        <a:srgbClr val="0E2356"/>
-                      </a:solidFill>
-                      <a:prstDash val="solid"/>
-                      <a:round/>
-                      <a:headEnd type="none" w="sm" len="sm"/>
-                      <a:tailEnd type="none" w="sm" len="sm"/>
-                    </a:lnT>
-                    <a:lnB w="12700" cap="flat" cmpd="sng">
-                      <a:solidFill>
-                        <a:srgbClr val="0E2356"/>
-                      </a:solidFill>
-                      <a:prstDash val="solid"/>
-                      <a:round/>
-                      <a:headEnd type="none" w="sm" len="sm"/>
-                      <a:tailEnd type="none" w="sm" len="sm"/>
-                    </a:lnB>
-                    <a:solidFill>
-                      <a:srgbClr val="C5D9E8"/>
-                    </a:solidFill>
-                  </a:tcPr>
-                </a:tc>
-                <a:tc>
-                  <a:txBody>
-                    <a:bodyPr/>
-                    <a:lstStyle/>
-                    <a:p>
-                      <a:pPr marL="82550" marR="0" lvl="0" indent="-82550" algn="ctr" rtl="0">
-                        <a:lnSpc>
-                          <a:spcPct val="100000"/>
-                        </a:lnSpc>
-                        <a:spcBef>
-                          <a:spcPts val="0"/>
-                        </a:spcBef>
-                        <a:spcAft>
-                          <a:spcPts val="0"/>
-                        </a:spcAft>
-                        <a:buClr>
-                          <a:srgbClr val="0E2356"/>
-                        </a:buClr>
-                        <a:buSzPts val="700"/>
-                        <a:buFont typeface="Outfit"/>
-                        <a:buNone/>
-                      </a:pPr>
-                      <a:r>
-                        <a:rPr lang="en-US" sz="700" b="1" i="0" u="none" strike="noStrike" cap="none">
-                          <a:solidFill>
-                            <a:srgbClr val="0E2356"/>
-                          </a:solidFill>
-                          <a:latin typeface="Outfit"/>
-                          <a:ea typeface="Outfit"/>
-                          <a:cs typeface="Outfit"/>
-                          <a:sym typeface="Outfit"/>
-                        </a:rPr>
-                        <a:t>Décision(s) </a:t>
-                      </a:r>
-                      <a:r>
-                        <a:rPr lang="en-US" sz="700" b="1">
-                          <a:latin typeface="Outfit"/>
-                          <a:ea typeface="Outfit"/>
-                          <a:cs typeface="Outfit"/>
-                          <a:sym typeface="Outfit"/>
-                        </a:rPr>
-                        <a:t>prises en séance</a:t>
-                      </a:r>
-                      <a:endParaRPr sz="1400" u="none" strike="noStrike" cap="none"/>
-                    </a:p>
-                  </a:txBody>
-                  <a:tcPr marL="68575" marR="68575" marT="0" marB="0" anchor="ctr">
-                    <a:lnL w="12700" cap="flat" cmpd="sng">
-                      <a:solidFill>
-                        <a:srgbClr val="0E2356"/>
-                      </a:solidFill>
-                      <a:prstDash val="solid"/>
-                      <a:round/>
-                      <a:headEnd type="none" w="sm" len="sm"/>
-                      <a:tailEnd type="none" w="sm" len="sm"/>
-                    </a:lnL>
-                    <a:lnR w="12700" cap="flat" cmpd="sng">
-                      <a:solidFill>
-                        <a:srgbClr val="0E2356"/>
-                      </a:solidFill>
-                      <a:prstDash val="solid"/>
-                      <a:round/>
-                      <a:headEnd type="none" w="sm" len="sm"/>
-                      <a:tailEnd type="none" w="sm" len="sm"/>
-                    </a:lnR>
-                    <a:lnT w="12700" cap="flat" cmpd="sng">
-                      <a:solidFill>
-                        <a:srgbClr val="0E2356"/>
-                      </a:solidFill>
-                      <a:prstDash val="solid"/>
-                      <a:round/>
-                      <a:headEnd type="none" w="sm" len="sm"/>
-                      <a:tailEnd type="none" w="sm" len="sm"/>
-                    </a:lnT>
-                    <a:lnB w="12700" cap="flat" cmpd="sng">
-                      <a:solidFill>
-                        <a:srgbClr val="0E2356"/>
-                      </a:solidFill>
-                      <a:prstDash val="solid"/>
-                      <a:round/>
-                      <a:headEnd type="none" w="sm" len="sm"/>
-                      <a:tailEnd type="none" w="sm" len="sm"/>
-                    </a:lnB>
-                    <a:solidFill>
-                      <a:srgbClr val="C5D9E8"/>
-                    </a:solidFill>
-                  </a:tcPr>
-                </a:tc>
-                <a:extLst>
-                  <a:ext uri="{0D108BD9-81ED-4DB2-BD59-A6C34878D82A}">
-                    <a16:rowId xmlns:a16="http://schemas.microsoft.com/office/drawing/2014/main" val="10000"/>
-                  </a:ext>
-                </a:extLst>
-              </a:tr>
-              <a:tr h="279000">
-                <a:tc gridSpan="2">
-                  <a:txBody>
-                    <a:bodyPr/>
-                    <a:lstStyle/>
-                    <a:p>
-                      <a:pPr marL="0" marR="0" lvl="0" indent="0" algn="l" rtl="0">
-                        <a:lnSpc>
-                          <a:spcPct val="100000"/>
-                        </a:lnSpc>
-                        <a:spcBef>
-                          <a:spcPts val="0"/>
-                        </a:spcBef>
-                        <a:spcAft>
-                          <a:spcPts val="0"/>
-                        </a:spcAft>
-                        <a:buClr>
-                          <a:srgbClr val="0E2356"/>
-                        </a:buClr>
-                        <a:buSzPts val="800"/>
-                        <a:buFont typeface="Outfit"/>
-                        <a:buNone/>
-                      </a:pPr>
-                      <a:r>
-                        <a:rPr lang="en-US" sz="800"/>
-                        <a:t>{{sujets_decision}}</a:t>
-                      </a:r>
-                      <a:endParaRPr sz="1400" u="none" strike="noStrike" cap="none"/>
-                    </a:p>
-                  </a:txBody>
-                  <a:tcPr marL="45725" marR="45725" marT="45725" marB="45725" anchor="ctr">
-                    <a:lnL w="12700" cap="flat" cmpd="sng">
-                      <a:solidFill>
-                        <a:srgbClr val="0E2356"/>
-                      </a:solidFill>
-                      <a:prstDash val="solid"/>
-                      <a:round/>
-                      <a:headEnd type="none" w="sm" len="sm"/>
-                      <a:tailEnd type="none" w="sm" len="sm"/>
-                    </a:lnL>
-                    <a:lnR w="12700" cap="flat" cmpd="sng">
-                      <a:solidFill>
-                        <a:srgbClr val="0E2356"/>
-                      </a:solidFill>
-                      <a:prstDash val="solid"/>
-                      <a:round/>
-                      <a:headEnd type="none" w="sm" len="sm"/>
-                      <a:tailEnd type="none" w="sm" len="sm"/>
-                    </a:lnR>
-                    <a:lnT w="12700" cap="flat" cmpd="sng">
-                      <a:solidFill>
-                        <a:srgbClr val="0E2356"/>
-                      </a:solidFill>
-                      <a:prstDash val="solid"/>
-                      <a:round/>
-                      <a:headEnd type="none" w="sm" len="sm"/>
-                      <a:tailEnd type="none" w="sm" len="sm"/>
-                    </a:lnT>
-                    <a:lnB w="12700" cap="flat" cmpd="sng">
-                      <a:solidFill>
-                        <a:srgbClr val="0E2356"/>
-                      </a:solidFill>
-                      <a:prstDash val="solid"/>
-                      <a:round/>
-                      <a:headEnd type="none" w="sm" len="sm"/>
-                      <a:tailEnd type="none" w="sm" len="sm"/>
-                    </a:lnB>
-                  </a:tcPr>
-                </a:tc>
-                <a:tc hMerge="1">
-                  <a:txBody>
-                    <a:bodyPr/>
-                    <a:lstStyle/>
-                    <a:p>
-                      <a:endParaRPr lang="fr-FR"/>
-                    </a:p>
-                  </a:txBody>
-                  <a:tcPr/>
-                </a:tc>
-                <a:tc>
-                  <a:txBody>
-                    <a:bodyPr/>
-                    <a:lstStyle/>
-                    <a:p>
-                      <a:pPr marL="0" marR="0" lvl="0" indent="0" algn="l" rtl="0">
-                        <a:lnSpc>
-                          <a:spcPct val="100000"/>
-                        </a:lnSpc>
-                        <a:spcBef>
-                          <a:spcPts val="0"/>
-                        </a:spcBef>
-                        <a:spcAft>
-                          <a:spcPts val="0"/>
-                        </a:spcAft>
-                        <a:buClr>
-                          <a:srgbClr val="0E2356"/>
-                        </a:buClr>
-                        <a:buSzPts val="800"/>
-                        <a:buFont typeface="Outfit"/>
-                        <a:buNone/>
-                      </a:pPr>
-                      <a:endParaRPr sz="1400" u="none" strike="noStrike" cap="none"/>
-                    </a:p>
-                  </a:txBody>
-                  <a:tcPr marL="68575" marR="68575" marT="0" marB="0" anchor="ctr">
-                    <a:lnL w="12700" cap="flat" cmpd="sng">
-                      <a:solidFill>
-                        <a:srgbClr val="0E2356"/>
-                      </a:solidFill>
-                      <a:prstDash val="solid"/>
-                      <a:round/>
-                      <a:headEnd type="none" w="sm" len="sm"/>
-                      <a:tailEnd type="none" w="sm" len="sm"/>
-                    </a:lnL>
-                    <a:lnR w="12700" cap="flat" cmpd="sng">
-                      <a:solidFill>
-                        <a:srgbClr val="0E2356"/>
-                      </a:solidFill>
-                      <a:prstDash val="solid"/>
-                      <a:round/>
-                      <a:headEnd type="none" w="sm" len="sm"/>
-                      <a:tailEnd type="none" w="sm" len="sm"/>
-                    </a:lnR>
-                    <a:lnT w="12700" cap="flat" cmpd="sng">
-                      <a:solidFill>
-                        <a:srgbClr val="0E2356"/>
-                      </a:solidFill>
-                      <a:prstDash val="solid"/>
-                      <a:round/>
-                      <a:headEnd type="none" w="sm" len="sm"/>
-                      <a:tailEnd type="none" w="sm" len="sm"/>
-                    </a:lnT>
-                    <a:lnB w="12700" cap="flat" cmpd="sng">
-                      <a:solidFill>
-                        <a:srgbClr val="0E2356"/>
-                      </a:solidFill>
-                      <a:prstDash val="solid"/>
-                      <a:round/>
-                      <a:headEnd type="none" w="sm" len="sm"/>
-                      <a:tailEnd type="none" w="sm" len="sm"/>
-                    </a:lnB>
-                  </a:tcPr>
-                </a:tc>
-                <a:extLst>
-                  <a:ext uri="{0D108BD9-81ED-4DB2-BD59-A6C34878D82A}">
-                    <a16:rowId xmlns:a16="http://schemas.microsoft.com/office/drawing/2014/main" val="10001"/>
-                  </a:ext>
-                </a:extLst>
-              </a:tr>
-              <a:tr h="283000">
-                <a:tc gridSpan="2">
-                  <a:txBody>
-                    <a:bodyPr/>
-                    <a:lstStyle/>
-                    <a:p>
-                      <a:pPr marL="0" marR="0" lvl="0" indent="0" algn="l" rtl="0">
-                        <a:lnSpc>
-                          <a:spcPct val="100000"/>
-                        </a:lnSpc>
-                        <a:spcBef>
-                          <a:spcPts val="0"/>
-                        </a:spcBef>
-                        <a:spcAft>
-                          <a:spcPts val="0"/>
-                        </a:spcAft>
-                        <a:buClr>
-                          <a:srgbClr val="0E2356"/>
-                        </a:buClr>
-                        <a:buSzPts val="800"/>
-                        <a:buFont typeface="Outfit"/>
-                        <a:buNone/>
-                      </a:pPr>
-                      <a:r>
-                        <a:rPr lang="en-US" sz="800"/>
-                        <a:t>{{decisions}}</a:t>
-                      </a:r>
-                      <a:endParaRPr sz="800" b="0" i="0" u="none" strike="noStrike" cap="none">
-                        <a:solidFill>
-                          <a:srgbClr val="0E2356"/>
-                        </a:solidFill>
-                        <a:latin typeface="Outfit"/>
-                        <a:ea typeface="Outfit"/>
-                        <a:cs typeface="Outfit"/>
-                        <a:sym typeface="Outfit"/>
-                      </a:endParaRPr>
-                    </a:p>
-                  </a:txBody>
-                  <a:tcPr marL="45725" marR="45725" marT="45725" marB="45725" anchor="ctr">
-                    <a:lnL w="12700" cap="flat" cmpd="sng">
-                      <a:solidFill>
-                        <a:srgbClr val="0E2356"/>
-                      </a:solidFill>
-                      <a:prstDash val="solid"/>
-                      <a:round/>
-                      <a:headEnd type="none" w="sm" len="sm"/>
-                      <a:tailEnd type="none" w="sm" len="sm"/>
-                    </a:lnL>
-                    <a:lnR w="12700" cap="flat" cmpd="sng">
-                      <a:solidFill>
-                        <a:srgbClr val="0E2356"/>
-                      </a:solidFill>
-                      <a:prstDash val="solid"/>
-                      <a:round/>
-                      <a:headEnd type="none" w="sm" len="sm"/>
-                      <a:tailEnd type="none" w="sm" len="sm"/>
-                    </a:lnR>
-                    <a:lnT w="12700" cap="flat" cmpd="sng">
-                      <a:solidFill>
-                        <a:srgbClr val="0E2356"/>
-                      </a:solidFill>
-                      <a:prstDash val="solid"/>
-                      <a:round/>
-                      <a:headEnd type="none" w="sm" len="sm"/>
-                      <a:tailEnd type="none" w="sm" len="sm"/>
-                    </a:lnT>
-                    <a:lnB w="12700" cap="flat" cmpd="sng">
-                      <a:solidFill>
-                        <a:srgbClr val="0E2356"/>
-                      </a:solidFill>
-                      <a:prstDash val="solid"/>
-                      <a:round/>
-                      <a:headEnd type="none" w="sm" len="sm"/>
-                      <a:tailEnd type="none" w="sm" len="sm"/>
-                    </a:lnB>
-                  </a:tcPr>
-                </a:tc>
-                <a:tc hMerge="1">
-                  <a:txBody>
-                    <a:bodyPr/>
-                    <a:lstStyle/>
-                    <a:p>
-                      <a:endParaRPr lang="fr-FR"/>
-                    </a:p>
-                  </a:txBody>
-                  <a:tcPr/>
-                </a:tc>
-                <a:tc>
-                  <a:txBody>
-                    <a:bodyPr/>
-                    <a:lstStyle/>
-                    <a:p>
-                      <a:pPr marL="0" marR="0" lvl="0" indent="0" algn="l" rtl="0">
-                        <a:lnSpc>
-                          <a:spcPct val="100000"/>
-                        </a:lnSpc>
-                        <a:spcBef>
-                          <a:spcPts val="0"/>
-                        </a:spcBef>
-                        <a:spcAft>
-                          <a:spcPts val="0"/>
-                        </a:spcAft>
-                        <a:buClr>
-                          <a:srgbClr val="0E2356"/>
-                        </a:buClr>
-                        <a:buSzPts val="800"/>
-                        <a:buFont typeface="Outfit"/>
-                        <a:buNone/>
-                      </a:pPr>
-                      <a:r>
-                        <a:rPr lang="en-US" sz="800" b="0" i="0" u="none" strike="noStrike" cap="none">
-                          <a:solidFill>
-                            <a:srgbClr val="0E2356"/>
-                          </a:solidFill>
-                          <a:latin typeface="Outfit"/>
-                          <a:ea typeface="Outfit"/>
-                          <a:cs typeface="Outfit"/>
-                          <a:sym typeface="Outfit"/>
-                        </a:rPr>
-                        <a:t>{{chantiers_3_mois}} - {{jalons_livrables}} - {{avancement_chantiers}} - {{difficultes_roadmap}}</a:t>
-                      </a:r>
-                      <a:endParaRPr sz="800" b="0" i="0" u="none" strike="noStrike" cap="none">
-                        <a:solidFill>
-                          <a:srgbClr val="0E2356"/>
-                        </a:solidFill>
-                        <a:latin typeface="Outfit"/>
-                        <a:ea typeface="Outfit"/>
-                        <a:cs typeface="Outfit"/>
-                        <a:sym typeface="Outfit"/>
-                      </a:endParaRPr>
-                    </a:p>
-                  </a:txBody>
-                  <a:tcPr marL="68575" marR="68575" marT="0" marB="0" anchor="ctr">
-                    <a:lnL w="12700" cap="flat" cmpd="sng">
-                      <a:solidFill>
-                        <a:srgbClr val="0E2356"/>
-                      </a:solidFill>
-                      <a:prstDash val="solid"/>
-                      <a:round/>
-                      <a:headEnd type="none" w="sm" len="sm"/>
-                      <a:tailEnd type="none" w="sm" len="sm"/>
-                    </a:lnL>
-                    <a:lnR w="12700" cap="flat" cmpd="sng">
-                      <a:solidFill>
-                        <a:srgbClr val="0E2356"/>
-                      </a:solidFill>
-                      <a:prstDash val="solid"/>
-                      <a:round/>
-                      <a:headEnd type="none" w="sm" len="sm"/>
-                      <a:tailEnd type="none" w="sm" len="sm"/>
-                    </a:lnR>
-                    <a:lnT w="12700" cap="flat" cmpd="sng">
-                      <a:solidFill>
-                        <a:srgbClr val="0E2356"/>
-                      </a:solidFill>
-                      <a:prstDash val="solid"/>
-                      <a:round/>
-                      <a:headEnd type="none" w="sm" len="sm"/>
-                      <a:tailEnd type="none" w="sm" len="sm"/>
-                    </a:lnT>
-                    <a:lnB w="12700" cap="flat" cmpd="sng">
-                      <a:solidFill>
-                        <a:srgbClr val="0E2356"/>
-                      </a:solidFill>
-                      <a:prstDash val="solid"/>
-                      <a:round/>
-                      <a:headEnd type="none" w="sm" len="sm"/>
-                      <a:tailEnd type="none" w="sm" len="sm"/>
-                    </a:lnB>
-                  </a:tcPr>
-                </a:tc>
-                <a:extLst>
-                  <a:ext uri="{0D108BD9-81ED-4DB2-BD59-A6C34878D82A}">
-                    <a16:rowId xmlns:a16="http://schemas.microsoft.com/office/drawing/2014/main" val="10002"/>
-                  </a:ext>
-                </a:extLst>
-              </a:tr>
-            </a:tbl>
-          </a:graphicData>
-        </a:graphic>
-      </p:graphicFrame>
       <p:sp>
         <p:nvSpPr>
           <p:cNvPr id="376" name="Google Shape;376;g3072d353d33_0_212"/>

</xml_diff>